<commit_message>
Exporta el guion a Word y lo mete en las notas del orador
Dos salidas de una sola fuente -docs/armar_guion.py-, para que no puedan
desincronizarse. El contenido vive en el script, no en el .docx ni en el
.pptx: editar un binario a mano es exactamente como se desincronizan las
cosas, y ya paso con la presentacion, que decia bcrypt meses despues de
migrar a Cognito.

El Word es para imprimir y ensayar: las 16 laminas con quien habla, el
tiempo de cada una y el acumulado, la lista de verificacion de cinco
minutos antes, la tabla de cortes de control y las seis preguntas
probables con su respuesta. En la paleta de Colsubsidio, como el resto.

Y las notas del orador del PowerPoint llevan lo mismo, lamina por lamina.
Eso es lo que de verdad van a mirar: en la vista de presentador el guion
sale al lado de la diapositiva, sin tener que seguir una hoja aparte
mientras se sostiene una tableta.

9:50 en total, con diez segundos de margen sobre los diez minutos.
</commit_message>
<xml_diff>
--- a/docs/CuentaVoz_Colsubsidio_V2.pptx
+++ b/docs/CuentaVoz_Colsubsidio_V2.pptx
@@ -452,8 +452,29 @@
           <a:lstStyle/>
           <a:p>
             <a:r>
-              <a:rPr lang="en-US" dirty="0"/>
-              <a:t>PITCH DE 5:00–5:30 · 0:00–0:05 (5s) — Preséntense en una frase: 'Somos StockXperts, esto es CuentaVoz.' No se detengan aquí, es solo la entrada.</a:t>
+              <a:t>LUIS  ·  0:20  ·  acumulado 0:20</a:t>
+            </a:r>
+          </a:p>
+          <a:p/>
+          <a:p>
+            <a:r>
+              <a:t>Buenos días. Somos StockXperts. Yo soy Luis, ella es Diana.</a:t>
+            </a:r>
+          </a:p>
+          <a:p>
+            <a:r>
+              <a:t>Traemos CuentaVoz: contar el inventario hablando, en vez de escribiendo.</a:t>
+            </a:r>
+          </a:p>
+          <a:p>
+            <a:r>
+              <a:t>En diez minutos se lo mostramos funcionando con los datos reales de ustedes.</a:t>
+            </a:r>
+          </a:p>
+          <a:p/>
+          <a:p>
+            <a:r>
+              <a:t>&gt; No lea la diapositiva: ya se ve.</a:t>
             </a:r>
           </a:p>
         </p:txBody>
@@ -539,8 +560,24 @@
           <a:lstStyle/>
           <a:p>
             <a:r>
-              <a:rPr lang="en-US" dirty="0"/>
-              <a:t>3:25–3:35 (10s) — Una frase: 'Ya tiene cifrado, huella digital, funciona sin internet.' SE PUEDE SALTAR COMPLETA si van cortos de tiempo.</a:t>
+              <a:t>LUIS  ·  0:30  ·  acumulado 7:10</a:t>
+            </a:r>
+          </a:p>
+          <a:p/>
+          <a:p>
+            <a:r>
+              <a:t>La identidad la maneja AWS Cognito, con verificación en dos pasos opcional. La clave nunca pasa por nuestro servidor.</a:t>
+            </a:r>
+          </a:p>
+          <a:p>
+            <a:r>
+              <a:t>Y nada se borra: una corrección crea un registro nuevo que apunta al original. La trazabilidad es completa.</a:t>
+            </a:r>
+          </a:p>
+          <a:p/>
+          <a:p>
+            <a:r>
+              <a:t>&gt; Al terminar esta lámina deberían ir en 7:10.</a:t>
             </a:r>
           </a:p>
         </p:txBody>
@@ -626,8 +663,24 @@
           <a:lstStyle/>
           <a:p>
             <a:r>
-              <a:rPr lang="en-US" dirty="0"/>
-              <a:t>3:35–3:55 (20s) — Menos error, más trazabilidad, escala a las 54 bodegas.</a:t>
+              <a:t>LUIS  ·  0:30  ·  acumulado 7:40</a:t>
+            </a:r>
+          </a:p>
+          <a:p/>
+          <a:p>
+            <a:r>
+              <a:t>Decisiones con datos reales, no con memoria ni planillas sueltas.</a:t>
+            </a:r>
+          </a:p>
+          <a:p>
+            <a:r>
+              <a:t>El auxiliar recupera tiempo, el administrador ve el estado en vivo.</a:t>
+            </a:r>
+          </a:p>
+          <a:p/>
+          <a:p>
+            <a:r>
+              <a:t>&gt; Una sola idea. No enumere las tres viñetas: escoja la que más le importe a quien tiene enfrente.</a:t>
             </a:r>
           </a:p>
         </p:txBody>
@@ -713,8 +766,13 @@
           <a:lstStyle/>
           <a:p>
             <a:r>
-              <a:rPr lang="en-US" dirty="0"/>
-              <a:t>3:55–4:10 (15s) — 'No hay licencias por usuario, se paga por uso de IA — bajo costo, alto impacto.' SE PUEDE SALTAR si van cortos.</a:t>
+              <a:t>DIANA  ·  0:30  ·  acumulado 8:10</a:t>
+            </a:r>
+          </a:p>
+          <a:p/>
+          <a:p>
+            <a:r>
+              <a:t>No hay licencias por usuario. Sumar una bodega o veinte personas más no cuesta más. Se paga la infraestructura y el consumo de la IA por uso.</a:t>
             </a:r>
           </a:p>
         </p:txBody>
@@ -800,8 +858,23 @@
           <a:lstStyle/>
           <a:p>
             <a:r>
-              <a:rPr lang="en-US" dirty="0"/>
-              <a:t>4:10–4:25 (15s) — 'Ya está en producción. El siguiente paso es un piloto real con ustedes.'</a:t>
+              <a:t>DIANA  ·  0:30  ·  acumulado 8:40</a:t>
+            </a:r>
+          </a:p>
+          <a:p/>
+          <a:p>
+            <a:r>
+              <a:t>Hoy: prototipo real desplegado y funcionando.</a:t>
+            </a:r>
+          </a:p>
+          <a:p>
+            <a:r>
+              <a:t>Próximo paso: cargar el archivo oficial de recetas y un piloto guiado en un grupo de bodegas.</a:t>
+            </a:r>
+          </a:p>
+          <a:p>
+            <a:r>
+              <a:t>Visión: toda la operación de hotelería, integrada con My Inventory.</a:t>
             </a:r>
           </a:p>
         </p:txBody>
@@ -887,8 +960,24 @@
           <a:lstStyle/>
           <a:p>
             <a:r>
-              <a:rPr lang="en-US" dirty="0"/>
-              <a:t>4:25–4:50 (25s) — EL ASK. NUNCA SE SALTA — esto es lo que se llevan los gerentes: un sponsor, el archivo de recetas, un grupo de bodegas para el piloto, 30 min cada 2 semanas.</a:t>
+              <a:t>LUIS  ·  0:40  ·  acumulado 9:20</a:t>
+            </a:r>
+          </a:p>
+          <a:p/>
+          <a:p>
+            <a:r>
+              <a:t>Para pasar del prototipo al piloto necesitamos cuatro cosas concretas: un SPONSOR dentro de Operaciones, un GRUPO DE BODEGAS para el piloto, el ARCHIVO OFICIAL DE RECETAS, y ACCESO A MY INVENTORY para cerrar el ciclo.</a:t>
+            </a:r>
+          </a:p>
+          <a:p/>
+          <a:p>
+            <a:r>
+              <a:t>&gt; ESTA LÁMINA NO SE SACRIFICA. Si va corto, recorte la 11 o la 12, nunca esta.</a:t>
+            </a:r>
+          </a:p>
+          <a:p>
+            <a:r>
+              <a:t>&gt; Mire a la persona que puede decir que sí.</a:t>
             </a:r>
           </a:p>
         </p:txBody>
@@ -974,8 +1063,13 @@
           <a:lstStyle/>
           <a:p>
             <a:r>
-              <a:rPr lang="en-US" dirty="0"/>
-              <a:t>4:50–5:00 (10s) — Nombres rápido, una frase de rol cada uno.</a:t>
+              <a:t>DIANA  ·  0:15  ·  acumulado 9:35</a:t>
+            </a:r>
+          </a:p>
+          <a:p/>
+          <a:p>
+            <a:r>
+              <a:t>Somos el equipo StockXperts. Esto lo construimos nosotros, de cero.</a:t>
             </a:r>
           </a:p>
         </p:txBody>
@@ -1061,9 +1155,19 @@
           <a:lstStyle/>
           <a:p>
             <a:r>
-              <a:rPr lang="en-US" dirty="0"/>
-              <a:t>5:00–5:10 (10s) — 'Muchas gracias por su tiempo. Quedamos atentos a sus preguntas — pueden escanear el código QR para explorar la demo ustedes mismos, y escribirnos directamente por WhatsApp al 313 389 8638.' Cierren con energía. NUNCA SE SALTA.
-RESUMEN DE TIEMPOS (total ~5:10, deja margen a 5:30): slides 2,3,6,9,14,16 nunca se saltan (son el hook, la solución, la demo, los datos reales, el ask y el cierre). Si van cortos, salten o abrevien 4, 5, 7, 10 y 12 en ese orden de prioridad.</a:t>
+              <a:t>LUIS  ·  0:15  ·  acumulado 9:50</a:t>
+            </a:r>
+          </a:p>
+          <a:p/>
+          <a:p>
+            <a:r>
+              <a:t>Ahí está la dirección para que lo prueben ustedes mismos, con estas cuentas. Quedamos atentos a sus preguntas.</a:t>
+            </a:r>
+          </a:p>
+          <a:p/>
+          <a:p>
+            <a:r>
+              <a:t>&gt; Deje esta lámina puesta durante las preguntas: tiene la URL, las cuentas y el contacto.</a:t>
             </a:r>
           </a:p>
         </p:txBody>
@@ -1149,8 +1253,24 @@
           <a:lstStyle/>
           <a:p>
             <a:r>
-              <a:rPr lang="en-US" dirty="0"/>
-              <a:t>0:05–0:30 (25s) — HOOK + PROBLEMA. Mencionen 1-2 ejemplos rápido (el 9 registrado como 90, o la unidad confundida) — no lean las 4 tarjetas completas. NUNCA SE SALTA.</a:t>
+              <a:t>LUIS  ·  0:40  ·  acumulado 1:00</a:t>
+            </a:r>
+          </a:p>
+          <a:p/>
+          <a:p>
+            <a:r>
+              <a:t>Hoy el inventario de una bodega se toma en papel. Alguien camina con una planilla, anota, y después otra persona lo digita en el sistema.</a:t>
+            </a:r>
+          </a:p>
+          <a:p>
+            <a:r>
+              <a:t>Eso tiene tres costos: TIEMPO —se hace dos veces—, ERRORES —de letra, de digitación— y DEMORA: la diferencia se descubre semanas después, cuando ya nadie se acuerda de qué pasó.</a:t>
+            </a:r>
+          </a:p>
+          <a:p/>
+          <a:p>
+            <a:r>
+              <a:t>&gt; Pausa corta antes de pasar.</a:t>
             </a:r>
           </a:p>
         </p:txBody>
@@ -1236,8 +1356,23 @@
           <a:lstStyle/>
           <a:p>
             <a:r>
-              <a:rPr lang="en-US" dirty="0"/>
-              <a:t>0:30–0:50 (20s) — QUÉ CONSTRUIMOS. 'Construimos CuentaVoz: usted habla, la IA entiende, el sistema valida y registra solo — sin papel, sin doble digitación.' NUNCA SE SALTA.</a:t>
+              <a:t>LUIS  ·  0:30  ·  acumulado 1:30</a:t>
+            </a:r>
+          </a:p>
+          <a:p/>
+          <a:p>
+            <a:r>
+              <a:t>Voz, inteligencia artificial y validaciones automáticas.</a:t>
+            </a:r>
+          </a:p>
+          <a:p>
+            <a:r>
+              <a:t>La persona habla, el sistema entiende, valida contra el inventario y guarda.</a:t>
+            </a:r>
+          </a:p>
+          <a:p>
+            <a:r>
+              <a:t>Una sola vez, en el sitio, y validado en el momento.</a:t>
             </a:r>
           </a:p>
         </p:txBody>
@@ -1323,8 +1458,24 @@
           <a:lstStyle/>
           <a:p>
             <a:r>
-              <a:rPr lang="en-US" dirty="0"/>
-              <a:t>0:50–1:10 (20s) — Si van cortos de tiempo, SE PUEDE SALTAR: solo digan una frase de transición ('el agente propone, el backend decide') y sigan.</a:t>
+              <a:t>DIANA  ·  0:40  ·  acumulado 2:10</a:t>
+            </a:r>
+          </a:p>
+          <a:p/>
+          <a:p>
+            <a:r>
+              <a:t>Cada vez que alguien habla pasan cinco pasos: escucha, interpreta, resuelve el artículo contra el catálogo oficial, valida y confirma.</a:t>
+            </a:r>
+          </a:p>
+          <a:p>
+            <a:r>
+              <a:t>Y algo importante: el modelo interpreta, pero el que decide es el backend. La inteligencia artificial no escribe en la base de datos — propone, y unas reglas en código deciden si eso entra o no.</a:t>
+            </a:r>
+          </a:p>
+          <a:p/>
+          <a:p>
+            <a:r>
+              <a:t>&gt; Ese matiz tranquiliza a quien pregunta por confiabilidad de la IA.</a:t>
             </a:r>
           </a:p>
         </p:txBody>
@@ -1410,8 +1561,24 @@
           <a:lstStyle/>
           <a:p>
             <a:r>
-              <a:rPr lang="en-US" dirty="0"/>
-              <a:t>1:10–1:25 (15s) — Mencionen rápido que cubre pedido, conteo y legalización — no se detengan en cada tarjeta. SE PUEDE SALTAR si van cortos.</a:t>
+              <a:t>DIANA  ·  0:40  ·  acumulado 2:50</a:t>
+            </a:r>
+          </a:p>
+          <a:p/>
+          <a:p>
+            <a:r>
+              <a:t>No es solo contar. Son los tres momentos del ciclo: el PEDIDO al almacén calculado por receta, el CONTEO de la bodega, y la LEGALIZACIÓN del servicio al final del turno.</a:t>
+            </a:r>
+          </a:p>
+          <a:p>
+            <a:r>
+              <a:t>Todo sin salir de la misma aplicación, con la misma voz.</a:t>
+            </a:r>
+          </a:p>
+          <a:p/>
+          <a:p>
+            <a:r>
+              <a:t>&gt; Al terminar esta lámina deberían ir en 2:50.</a:t>
             </a:r>
           </a:p>
         </p:txBody>
@@ -1497,8 +1664,80 @@
           <a:lstStyle/>
           <a:p>
             <a:r>
-              <a:rPr lang="en-US" dirty="0"/>
-              <a:t>1:25–2:25 (60s) — DEMO EN VIVO, la parte más importante. Aquí PAUSEN las diapositivas: saquen la tablet y hagan un conteo de verdad hablándole al agente; si el público tiene celular a mano, que abran cuentavoz.onrender.com y sigan en vivo (usuario luis/diana, PIN StockXperts). Esta slide con las capturas queda de RESPALDO si falla el wifi de la sede — no lean las descripciones, salten directo a la app real. NUNCA SE SALTA.</a:t>
+              <a:t>LUIS cuenta · DIANA cierra  ·  2:00  ·  acumulado 4:50</a:t>
+            </a:r>
+          </a:p>
+          <a:p/>
+          <a:p>
+            <a:r>
+              <a:t>LUIS (1:10) — como auxiliar:</a:t>
+            </a:r>
+          </a:p>
+          <a:p>
+            <a:r>
+              <a:t>1. Entro como auxiliar. Solo veo MIS bodegas asignadas, ninguna más.</a:t>
+            </a:r>
+          </a:p>
+          <a:p>
+            <a:r>
+              <a:t>2. Abre una bodega. «Ya está abierta, con sus 133 referencias.»</a:t>
+            </a:r>
+          </a:p>
+          <a:p>
+            <a:r>
+              <a:t>3. Toca el micrófono y dicta despacio: «papa criolla veinte kilos».</a:t>
+            </a:r>
+          </a:p>
+          <a:p>
+            <a:r>
+              <a:t>4. Me repite lo que entendió y me pide confirmar. → confirma.</a:t>
+            </a:r>
+          </a:p>
+          <a:p>
+            <a:r>
+              <a:t>5. Si sale diferencia: «Aquí me avisa que el sistema esperaba otra cantidad. ESTO es el hallazgo: se ve ahora, no en tres semanas.»</a:t>
+            </a:r>
+          </a:p>
+          <a:p>
+            <a:r>
+              <a:t>6. Cuando termino, firmo mi conteo. → «Terminar y firmar mi conteo».</a:t>
+            </a:r>
+          </a:p>
+          <a:p/>
+          <a:p>
+            <a:r>
+              <a:t>DIANA (0:50) — como administradora:</a:t>
+            </a:r>
+          </a:p>
+          <a:p>
+            <a:r>
+              <a:t>7. Yo recibo esa bodega firmada y hago el RECUENTO CIEGO: cuento sin ver sus números.</a:t>
+            </a:r>
+          </a:p>
+          <a:p>
+            <a:r>
+              <a:t>8. Muestra la comparación: «aquí se revelan las tres columnas: el sistema, lo que contó Luis, lo que conté yo».</a:t>
+            </a:r>
+          </a:p>
+          <a:p>
+            <a:r>
+              <a:t>9. Y se cierra con DOBLE FIRMA. Ninguno de los dos puede cerrar solo.</a:t>
+            </a:r>
+          </a:p>
+          <a:p/>
+          <a:p>
+            <a:r>
+              <a:t>&gt; NO use las capturas: abra la tableta.</a:t>
+            </a:r>
+          </a:p>
+          <a:p>
+            <a:r>
+              <a:t>&gt; Si el micrófono falla, toque Teclado y escriba la misma frase. Es el respaldo real de la aplicación, no una excusa: dígalo así, «funciona en una bodega con ruido».</a:t>
+            </a:r>
+          </a:p>
+          <a:p>
+            <a:r>
+              <a:t>&gt; CORTE: si a los 5:00 no han salido de la demo, córtenla y sigan.</a:t>
             </a:r>
           </a:p>
         </p:txBody>
@@ -1584,8 +1823,18 @@
           <a:lstStyle/>
           <a:p>
             <a:r>
-              <a:rPr lang="en-US" dirty="0"/>
-              <a:t>2:25–2:45 (20s) — Un solo ejemplo fuerte: 'noventa cazuelas' dispara '¿confirma 90?'. No lean las 4 tarjetas. SE PUEDE ABREVIAR a una frase si la demo en vivo se alargó.</a:t>
+              <a:t>LUIS  ·  0:40  ·  acumulado 5:30</a:t>
+            </a:r>
+          </a:p>
+          <a:p/>
+          <a:p>
+            <a:r>
+              <a:t>Lo que acaban de ver validó cuatro cosas sin que yo hiciera nada: que el artículo existe en el catálogo, que la unidad es la correcta, que la cantidad tiene sentido, y que yo tenía permiso sobre esa bodega.</a:t>
+            </a:r>
+          </a:p>
+          <a:p>
+            <a:r>
+              <a:t>Si algo no cuadra, el conteo NO se detiene: queda marcado y sigue.</a:t>
             </a:r>
           </a:p>
         </p:txBody>
@@ -1671,8 +1920,24 @@
           <a:lstStyle/>
           <a:p>
             <a:r>
-              <a:rPr lang="en-US" dirty="0"/>
-              <a:t>2:45–3:00 (15s) — TECH STACK en una frase: React, FastAPI, PostgreSQL, Gemini, todo en producción en Render. No se detengan en el diagrama completo.</a:t>
+              <a:t>DIANA  ·  0:40  ·  acumulado 6:10</a:t>
+            </a:r>
+          </a:p>
+          <a:p/>
+          <a:p>
+            <a:r>
+              <a:t>Está en AWS: el frontend en S3 con CloudFront, el backend en EC2 con Docker, la base en RDS. La misma nube que ya usa Colsubsidio, así que no hay nada que migrar.</a:t>
+            </a:r>
+          </a:p>
+          <a:p>
+            <a:r>
+              <a:t>Y cada cambio pasa por 149 pruebas automáticas antes de desplegarse. Si una falla, no llega a producción.</a:t>
+            </a:r>
+          </a:p>
+          <a:p/>
+          <a:p>
+            <a:r>
+              <a:t>&gt; Es la lámina donde más preguntan. No se extienda: si preguntan, hay tiempo al final.</a:t>
             </a:r>
           </a:p>
         </p:txBody>
@@ -1758,8 +2023,18 @@
           <a:lstStyle/>
           <a:p>
             <a:r>
-              <a:rPr lang="en-US" dirty="0"/>
-              <a:t>3:00–3:25 (25s) — Estos números importan: 54 bodegas, 1.040 artículos, 88.2% de exactitud — con el archivo real que entregó Colsubsidio, no una demo inventada. NUNCA SE SALTA.</a:t>
+              <a:t>DIANA  ·  0:30  ·  acumulado 6:40</a:t>
+            </a:r>
+          </a:p>
+          <a:p/>
+          <a:p>
+            <a:r>
+              <a:t>Nada de esto es una maqueta: son las 54 bodegas de ustedes, 1.041 artículos del catálogo oficial y 1.405 registros de stock.</a:t>
+            </a:r>
+          </a:p>
+          <a:p>
+            <a:r>
+              <a:t>Al cargarlo, el sistema encontró 79 saldos negativos — inventario que el sistema dice tener en menos que cero.</a:t>
             </a:r>
           </a:p>
         </p:txBody>

</xml_diff>

<commit_message>
Actualiza el codigo QR, que mandaba al despliegue viejo de Render
El QR de la ultima diapositiva apuntaba a https://cuentavoz.onrender.com.
Cambiar la URL escrita al lado no lo actualiza: el QR es una imagen, y se
ve exactamente igual apunte a donde apunte. Quien lo escaneara durante la
presentacion habria aterrizado en Render en vez de en la plataforma.

Es el tipo de error que no aparece revisando el texto de las laminas -yo
mismo lo marque como "no puedo tocarlo" al actualizar la presentacion- y
que solo sale decodificando la imagen. Por eso docs/actualizar_qr.py
decodifica el QR generado antes de darlo por bueno, y vuelve a
decodificarlo desde el archivo guardado al terminar.

Se cambia en las dos versiones, la de las tres capturas y la del GIF, y se
comprueba que la URL impresa al lado diga lo mismo que el QR.
</commit_message>
<xml_diff>
--- a/docs/CuentaVoz_Colsubsidio_V2.pptx
+++ b/docs/CuentaVoz_Colsubsidio_V2.pptx
@@ -10393,16 +10393,55 @@
           </a:p>
         </p:txBody>
       </p:sp>
+      <p:sp>
+        <p:nvSpPr>
+          <p:cNvPr id="28" name="Text 20"/>
+          <p:cNvSpPr/>
+          <p:nvPr/>
+        </p:nvSpPr>
+        <p:spPr>
+          <a:xfrm>
+            <a:off x="9482328" y="3163824"/>
+            <a:ext cx="2066544" cy="320040"/>
+          </a:xfrm>
+          <a:prstGeom prst="rect">
+            <a:avLst/>
+          </a:prstGeom>
+          <a:noFill/>
+          <a:ln/>
+        </p:spPr>
+        <p:txBody>
+          <a:bodyPr wrap="square" lIns="0" tIns="0" rIns="0" bIns="0" rtlCol="0" anchor="ctr"/>
+          <a:lstStyle/>
+          <a:p>
+            <a:pPr marL="0" indent="0" algn="ctr">
+              <a:buNone/>
+            </a:pPr>
+            <a:r>
+              <a:rPr lang="en-US" sz="1050" b="1" dirty="0">
+                <a:solidFill>
+                  <a:srgbClr val="10294C"/>
+                </a:solidFill>
+                <a:latin typeface="Calibri" pitchFamily="34" charset="0"/>
+                <a:ea typeface="Calibri" pitchFamily="34" charset="-122"/>
+                <a:cs typeface="Calibri" pitchFamily="34" charset="-120"/>
+              </a:rPr>
+              <a:t>Escanea y pruébelo</a:t>
+            </a:r>
+            <a:endParaRPr lang="en-US" sz="1050" dirty="0"/>
+          </a:p>
+        </p:txBody>
+      </p:sp>
       <p:pic>
         <p:nvPicPr>
-          <p:cNvPr id="27" name="Image 5" descr="/tmp/claude-0/-home-user-cuentavoz/fdf2c082-f526-5e3d-b5a9-2784467fe58c/scratchpad/pitch/icons/qr_demo.png"/>
+          <p:cNvPr id="29" name="Picture 28" descr="_qr_tmp.png"/>
           <p:cNvPicPr>
             <a:picLocks noChangeAspect="1"/>
           </p:cNvPicPr>
           <p:nvPr/>
         </p:nvPicPr>
         <p:blipFill>
-          <a:blip r:embed="rId8"/>
+          <a:blip r:embed="rId9"/>
           <a:stretch>
             <a:fillRect/>
           </a:stretch>
@@ -10417,45 +10456,6 @@
           </a:prstGeom>
         </p:spPr>
       </p:pic>
-      <p:sp>
-        <p:nvSpPr>
-          <p:cNvPr id="28" name="Text 20"/>
-          <p:cNvSpPr/>
-          <p:nvPr/>
-        </p:nvSpPr>
-        <p:spPr>
-          <a:xfrm>
-            <a:off x="9482328" y="3163824"/>
-            <a:ext cx="2066544" cy="320040"/>
-          </a:xfrm>
-          <a:prstGeom prst="rect">
-            <a:avLst/>
-          </a:prstGeom>
-          <a:noFill/>
-          <a:ln/>
-        </p:spPr>
-        <p:txBody>
-          <a:bodyPr wrap="square" lIns="0" tIns="0" rIns="0" bIns="0" rtlCol="0" anchor="ctr"/>
-          <a:lstStyle/>
-          <a:p>
-            <a:pPr marL="0" indent="0" algn="ctr">
-              <a:buNone/>
-            </a:pPr>
-            <a:r>
-              <a:rPr lang="en-US" sz="1050" b="1" dirty="0">
-                <a:solidFill>
-                  <a:srgbClr val="10294C"/>
-                </a:solidFill>
-                <a:latin typeface="Calibri" pitchFamily="34" charset="0"/>
-                <a:ea typeface="Calibri" pitchFamily="34" charset="-122"/>
-                <a:cs typeface="Calibri" pitchFamily="34" charset="-120"/>
-              </a:rPr>
-              <a:t>Escanea y pruébelo</a:t>
-            </a:r>
-            <a:endParaRPr lang="en-US" sz="1050" dirty="0"/>
-          </a:p>
-        </p:txBody>
-      </p:sp>
     </p:spTree>
   </p:cSld>
   <p:clrMapOvr>

</xml_diff>